<commit_message>
Update final MasterFlow presentation
</commit_message>
<xml_diff>
--- a/submission/MasterFlow_Slides.pptx
+++ b/submission/MasterFlow_Slides.pptx
@@ -4,6 +4,9 @@
   <p:sldMasterIdLst>
     <p:sldMasterId id="2147483648" r:id="rId1"/>
   </p:sldMasterIdLst>
+  <p:notesMasterIdLst>
+    <p:notesMasterId r:id="rId7"/>
+  </p:notesMasterIdLst>
   <p:sldIdLst>
     <p:sldId id="256" r:id="rId2"/>
     <p:sldId id="257" r:id="rId3"/>
@@ -11,9 +14,6 @@
     <p:sldId id="259" r:id="rId5"/>
     <p:sldId id="260" r:id="rId6"/>
   </p:sldIdLst>
-  <p:notesMasterIdLst>
-    <p:notesMasterId r:id="rId7"/>
-  </p:notesMasterIdLst>
   <p:sldSz cx="12192000" cy="6858000"/>
   <p:notesSz cx="6858000" cy="12192000"/>
   <p:defaultTextStyle>
@@ -108,6 +108,11 @@
       </a:defRPr>
     </a:lvl9pPr>
   </p:defaultTextStyle>
+  <p:extLst>
+    <p:ext uri="{EFAFB233-063F-42B5-8137-9DF3F51BA10A}">
+      <p15:sldGuideLst xmlns:p15="http://schemas.microsoft.com/office/powerpoint/2012/main"/>
+    </p:ext>
+  </p:extLst>
 </p:presentation>
 </file>
 
@@ -133,234 +138,10 @@
           <a:chExt cx="0" cy="0"/>
         </a:xfrm>
       </p:grpSpPr>
-      <p:sp>
-        <p:nvSpPr>
-          <p:cNvPr id="2" name="Header Placeholder 1"/>
-          <p:cNvSpPr>
-            <a:spLocks noGrp="1"/>
-          </p:cNvSpPr>
-          <p:nvPr>
-            <p:ph type="hdr" sz="quarter"/>
-          </p:nvPr>
-        </p:nvSpPr>
-        <p:spPr>
-          <a:xfrm>
-            <a:off x="0" y="0"/>
-            <a:ext cx="2971800" cy="458788"/>
-          </a:xfrm>
-          <a:prstGeom prst="rect">
-            <a:avLst/>
-          </a:prstGeom>
-        </p:spPr>
-        <p:txBody>
-          <a:bodyPr vert="horz" lIns="91440" tIns="45720" rIns="91440" bIns="45720" rtlCol="0"/>
-          <a:lstStyle>
-            <a:lvl1pPr algn="l">
-              <a:defRPr sz="1200"/>
-            </a:lvl1pPr>
-          </a:lstStyle>
-          <a:p>
-            <a:endParaRPr lang="en-US"/>
-          </a:p>
-        </p:txBody>
-      </p:sp>
-      <p:sp>
-        <p:nvSpPr>
-          <p:cNvPr id="3" name="Date Placeholder 2"/>
-          <p:cNvSpPr>
-            <a:spLocks noGrp="1"/>
-          </p:cNvSpPr>
-          <p:nvPr>
-            <p:ph type="dt" idx="1"/>
-          </p:nvPr>
-        </p:nvSpPr>
-        <p:spPr>
-          <a:xfrm>
-            <a:off x="3884613" y="0"/>
-            <a:ext cx="2971800" cy="458788"/>
-          </a:xfrm>
-          <a:prstGeom prst="rect">
-            <a:avLst/>
-          </a:prstGeom>
-        </p:spPr>
-        <p:txBody>
-          <a:bodyPr vert="horz" lIns="91440" tIns="45720" rIns="91440" bIns="45720" rtlCol="0"/>
-          <a:lstStyle>
-            <a:lvl1pPr algn="r">
-              <a:defRPr sz="1200"/>
-            </a:lvl1pPr>
-          </a:lstStyle>
-          <a:p>
-            <a:fld id="{5282F153-3F37-0F45-9E97-73ACFA13230C}" type="datetimeFigureOut">
-              <a:rPr lang="en-US"/>
-              <a:t>7/23/19</a:t>
-            </a:fld>
-            <a:endParaRPr lang="en-US"/>
-          </a:p>
-        </p:txBody>
-      </p:sp>
-      <p:sp>
-        <p:nvSpPr>
-          <p:cNvPr id="4" name="Slide Image Placeholder 3"/>
-          <p:cNvSpPr>
-            <a:spLocks noGrp="1" noRot="1" noChangeAspect="1"/>
-          </p:cNvSpPr>
-          <p:nvPr>
-            <p:ph type="sldImg" idx="2"/>
-          </p:nvPr>
-        </p:nvSpPr>
-        <p:spPr>
-          <a:xfrm>
-            <a:off x="685800" y="1143000"/>
-            <a:ext cx="5486400" cy="3086100"/>
-          </a:xfrm>
-          <a:prstGeom prst="rect">
-            <a:avLst/>
-          </a:prstGeom>
-          <a:noFill/>
-          <a:ln w="12700">
-            <a:solidFill>
-              <a:prstClr val="black"/>
-            </a:solidFill>
-          </a:ln>
-        </p:spPr>
-        <p:txBody>
-          <a:bodyPr vert="horz" lIns="91440" tIns="45720" rIns="91440" bIns="45720" rtlCol="0" anchor="ctr"/>
-          <a:lstStyle/>
-          <a:p>
-            <a:endParaRPr lang="en-US"/>
-          </a:p>
-        </p:txBody>
-      </p:sp>
-      <p:sp>
-        <p:nvSpPr>
-          <p:cNvPr id="5" name="Notes Placeholder 4"/>
-          <p:cNvSpPr>
-            <a:spLocks noGrp="1"/>
-          </p:cNvSpPr>
-          <p:nvPr>
-            <p:ph type="body" sz="quarter" idx="3"/>
-          </p:nvPr>
-        </p:nvSpPr>
-        <p:spPr>
-          <a:xfrm>
-            <a:off x="685800" y="4400550"/>
-            <a:ext cx="5486400" cy="3600450"/>
-          </a:xfrm>
-          <a:prstGeom prst="rect">
-            <a:avLst/>
-          </a:prstGeom>
-        </p:spPr>
-        <p:txBody>
-          <a:bodyPr vert="horz" lIns="91440" tIns="45720" rIns="91440" bIns="45720" rtlCol="0"/>
-          <a:lstStyle/>
-          <a:p>
-            <a:pPr lvl="0"/>
-            <a:r>
-              <a:rPr lang="en-US"/>
-              <a:t>Click to edit Master text styles</a:t>
-            </a:r>
-          </a:p>
-          <a:p>
-            <a:pPr lvl="1"/>
-            <a:r>
-              <a:rPr lang="en-US"/>
-              <a:t>Second level</a:t>
-            </a:r>
-          </a:p>
-          <a:p>
-            <a:pPr lvl="2"/>
-            <a:r>
-              <a:rPr lang="en-US"/>
-              <a:t>Third level</a:t>
-            </a:r>
-          </a:p>
-          <a:p>
-            <a:pPr lvl="3"/>
-            <a:r>
-              <a:rPr lang="en-US"/>
-              <a:t>Fourth level</a:t>
-            </a:r>
-          </a:p>
-          <a:p>
-            <a:pPr lvl="4"/>
-            <a:r>
-              <a:rPr lang="en-US"/>
-              <a:t>Fifth level</a:t>
-            </a:r>
-          </a:p>
-        </p:txBody>
-      </p:sp>
-      <p:sp>
-        <p:nvSpPr>
-          <p:cNvPr id="6" name="Footer Placeholder 5"/>
-          <p:cNvSpPr>
-            <a:spLocks noGrp="1"/>
-          </p:cNvSpPr>
-          <p:nvPr>
-            <p:ph type="ftr" sz="quarter" idx="4"/>
-          </p:nvPr>
-        </p:nvSpPr>
-        <p:spPr>
-          <a:xfrm>
-            <a:off x="0" y="8685213"/>
-            <a:ext cx="2971800" cy="458787"/>
-          </a:xfrm>
-          <a:prstGeom prst="rect">
-            <a:avLst/>
-          </a:prstGeom>
-        </p:spPr>
-        <p:txBody>
-          <a:bodyPr vert="horz" lIns="91440" tIns="45720" rIns="91440" bIns="45720" rtlCol="0" anchor="b"/>
-          <a:lstStyle>
-            <a:lvl1pPr algn="l">
-              <a:defRPr sz="1200"/>
-            </a:lvl1pPr>
-          </a:lstStyle>
-          <a:p>
-            <a:endParaRPr lang="en-US"/>
-          </a:p>
-        </p:txBody>
-      </p:sp>
-      <p:sp>
-        <p:nvSpPr>
-          <p:cNvPr id="7" name="Slide Number Placeholder 6"/>
-          <p:cNvSpPr>
-            <a:spLocks noGrp="1"/>
-          </p:cNvSpPr>
-          <p:nvPr>
-            <p:ph type="sldNum" sz="quarter" idx="5"/>
-          </p:nvPr>
-        </p:nvSpPr>
-        <p:spPr>
-          <a:xfrm>
-            <a:off x="3884613" y="8685213"/>
-            <a:ext cx="2971800" cy="458787"/>
-          </a:xfrm>
-          <a:prstGeom prst="rect">
-            <a:avLst/>
-          </a:prstGeom>
-        </p:spPr>
-        <p:txBody>
-          <a:bodyPr vert="horz" lIns="91440" tIns="45720" rIns="91440" bIns="45720" rtlCol="0" anchor="b"/>
-          <a:lstStyle>
-            <a:lvl1pPr algn="r">
-              <a:defRPr sz="1200"/>
-            </a:lvl1pPr>
-          </a:lstStyle>
-          <a:p>
-            <a:fld id="{CE5E9CC1-C706-0F49-92D6-E571CC5EEA8F}" type="slidenum">
-              <a:rPr lang="en-US"/>
-              <a:t>‹#›</a:t>
-            </a:fld>
-            <a:endParaRPr lang="en-US"/>
-          </a:p>
-        </p:txBody>
-      </p:sp>
     </p:spTree>
     <p:extLst>
       <p:ext uri="{BB962C8B-B14F-4D97-AF65-F5344CB8AC3E}">
-        <p14:creationId xmlns:p14="http://schemas.microsoft.com/office/powerpoint/2010/main" val="1024086991"/>
+        <p14:creationId xmlns:p14="http://schemas.microsoft.com/office/powerpoint/2010/main" val="1608660988"/>
       </p:ext>
     </p:extLst>
   </p:cSld>
@@ -508,7 +289,6 @@
               <a:rPr lang="en-US" dirty="0"/>
               <a:t>MasterFlow is a working, dependency-free prototype for Problem #4 — replacing an expensive ServiceNow catalog with one simple, AI-assisted request front door while preserving existing queues, SLAs, and approvals.</a:t>
             </a:r>
-            <a:endParaRPr lang="en-US" dirty="0"/>
           </a:p>
         </p:txBody>
       </p:sp>
@@ -596,7 +376,6 @@
               <a:rPr lang="en-US" dirty="0"/>
               <a:t>The core problem is usability and cost, not routing. Employees know what they need but must find the right catalog item and fill a different form each time. MasterFlow keeps the trusted routing and replaces the friction.</a:t>
             </a:r>
-            <a:endParaRPr lang="en-US" dirty="0"/>
           </a:p>
         </p:txBody>
       </p:sp>
@@ -684,7 +463,6 @@
               <a:rPr lang="en-US" dirty="0"/>
               <a:t>Classification, extraction, and the diagnostic question flow are transparent and local — no black box. Low-confidence requests route to Triage instead of guessing. A Node regression harness asserts the classification of every home-page example phrase.</a:t>
             </a:r>
-            <a:endParaRPr lang="en-US" dirty="0"/>
           </a:p>
         </p:txBody>
       </p:sp>
@@ -772,7 +550,6 @@
               <a:rPr lang="en-US" dirty="0"/>
               <a:t>Six connected surfaces cover every Problem #4 requirement: create/track/close tickets with standard fields, configurable queues and routing, SLAs, two-way communication and simulated email intake, knowledge base, incident/service/change with approvals, reporting, roles and access, ServiceNow migration, AI assistance, lower cost, and no-code configuration.</a:t>
             </a:r>
-            <a:endParaRPr lang="en-US" dirty="0"/>
           </a:p>
         </p:txBody>
       </p:sp>
@@ -860,7 +637,6 @@
               <a:rPr lang="en-US" dirty="0"/>
               <a:t>Impact: a credible path off a $300K/year system, with all twelve requirements demonstrated and no runtime dependencies. Next steps move from prototype to production: SSO, live migration, measured savings reconciliation, CI-enforced classification tests, and real email/notifications.</a:t>
             </a:r>
-            <a:endParaRPr lang="en-US" dirty="0"/>
           </a:p>
         </p:txBody>
       </p:sp>
@@ -933,6 +709,11 @@
 <file path=ppt/slideMasters/slideMaster1.xml><?xml version="1.0" encoding="utf-8"?>
 <p:sldMaster xmlns:a="http://schemas.openxmlformats.org/drawingml/2006/main" xmlns:r="http://schemas.openxmlformats.org/officeDocument/2006/relationships" xmlns:p="http://schemas.openxmlformats.org/presentationml/2006/main">
   <p:cSld>
+    <p:bg>
+      <p:bgRef idx="1001">
+        <a:schemeClr val="bg1"/>
+      </p:bgRef>
+    </p:bg>
     <p:spTree>
       <p:nvGrpSpPr>
         <p:cNvPr id="1" name=""/>
@@ -947,6 +728,54 @@
           <a:chExt cx="0" cy="0"/>
         </a:xfrm>
       </p:grpSpPr>
+      <p:sp>
+        <p:nvSpPr>
+          <p:cNvPr id="3" name="TextBox 2">
+            <a:extLst>
+              <a:ext uri="{FF2B5EF4-FFF2-40B4-BE49-F238E27FC236}">
+                <a16:creationId xmlns:a16="http://schemas.microsoft.com/office/drawing/2014/main" id="{FF446A12-B574-0B15-1DC4-82E63BBDCCD6}"/>
+              </a:ext>
+            </a:extLst>
+          </p:cNvPr>
+          <p:cNvSpPr txBox="1"/>
+          <p:nvPr userDrawn="1">
+            <p:extLst>
+              <p:ext uri="{1162E1C5-73C7-4A58-AE30-91384D911F3F}">
+                <p184:classification xmlns:p184="http://schemas.microsoft.com/office/powerpoint/2018/4/main" val="hdr"/>
+              </p:ext>
+            </p:extLst>
+          </p:nvPr>
+        </p:nvSpPr>
+        <p:spPr>
+          <a:xfrm>
+            <a:off x="63500" y="63500"/>
+            <a:ext cx="581025" cy="152400"/>
+          </a:xfrm>
+          <a:prstGeom prst="rect">
+            <a:avLst/>
+          </a:prstGeom>
+        </p:spPr>
+        <p:txBody>
+          <a:bodyPr horzOverflow="overflow" lIns="0" tIns="0" rIns="0" bIns="0">
+            <a:spAutoFit/>
+          </a:bodyPr>
+          <a:lstStyle/>
+          <a:p>
+            <a:pPr algn="l"/>
+            <a:r>
+              <a:rPr lang="en-US" sz="1000">
+                <a:solidFill>
+                  <a:srgbClr val="0000FF">
+                    <a:alpha val="50000"/>
+                  </a:srgbClr>
+                </a:solidFill>
+                <a:latin typeface="Aptos" panose="020B0004020202020204" pitchFamily="34" charset="0"/>
+              </a:rPr>
+              <a:t>INTERNAL</a:t>
+            </a:r>
+          </a:p>
+        </p:txBody>
+      </p:sp>
     </p:spTree>
   </p:cSld>
   <p:clrMap bg1="lt1" tx1="dk1" bg2="lt2" tx2="dk2" accent1="accent1" accent2="accent2" accent3="accent3" accent4="accent4" accent5="accent5" accent6="accent6" hlink="hlink" folHlink="folHlink"/>
@@ -1215,6 +1044,7 @@
         <a:solidFill>
           <a:srgbClr val="16224A"/>
         </a:solidFill>
+        <a:effectLst/>
       </p:bgPr>
     </p:bg>
     <p:spTree>
@@ -1250,6 +1080,13 @@
           </a:solidFill>
           <a:ln/>
         </p:spPr>
+        <p:txBody>
+          <a:bodyPr/>
+          <a:lstStyle/>
+          <a:p>
+            <a:endParaRPr lang="en-US"/>
+          </a:p>
+        </p:txBody>
       </p:sp>
       <p:sp>
         <p:nvSpPr>
@@ -1272,6 +1109,13 @@
           </a:solidFill>
           <a:ln/>
         </p:spPr>
+        <p:txBody>
+          <a:bodyPr/>
+          <a:lstStyle/>
+          <a:p>
+            <a:endParaRPr lang="en-US"/>
+          </a:p>
+        </p:txBody>
       </p:sp>
       <p:sp>
         <p:nvSpPr>
@@ -1294,11 +1138,11 @@
           <a:bodyPr wrap="square" lIns="0" tIns="0" rIns="0" bIns="0" rtlCol="0" anchor="ctr"/>
           <a:lstStyle/>
           <a:p>
-            <a:pPr indent="0" marL="0">
-              <a:buNone/>
-            </a:pPr>
-            <a:r>
-              <a:rPr lang="en-US" sz="1250" b="1" spc="200" kern="0" dirty="0">
+            <a:pPr marL="0" indent="0">
+              <a:buNone/>
+            </a:pPr>
+            <a:r>
+              <a:rPr lang="en-US" sz="1250" b="1" kern="0" spc="200" dirty="0">
                 <a:solidFill>
                   <a:srgbClr val="CADCFC"/>
                 </a:solidFill>
@@ -1333,7 +1177,7 @@
           <a:bodyPr wrap="square" lIns="0" tIns="0" rIns="0" bIns="0" rtlCol="0" anchor="ctr"/>
           <a:lstStyle/>
           <a:p>
-            <a:pPr indent="0" marL="0">
+            <a:pPr marL="0" indent="0">
               <a:buNone/>
             </a:pPr>
             <a:r>
@@ -1372,7 +1216,7 @@
           <a:bodyPr wrap="square" lIns="0" tIns="0" rIns="0" bIns="0" rtlCol="0" anchor="ctr"/>
           <a:lstStyle/>
           <a:p>
-            <a:pPr indent="0" marL="0">
+            <a:pPr marL="0" indent="0">
               <a:lnSpc>
                 <a:spcPct val="112000"/>
               </a:lnSpc>
@@ -1419,6 +1263,13 @@
             <a:prstDash val="solid"/>
           </a:ln>
         </p:spPr>
+        <p:txBody>
+          <a:bodyPr/>
+          <a:lstStyle/>
+          <a:p>
+            <a:endParaRPr lang="en-US"/>
+          </a:p>
+        </p:txBody>
       </p:sp>
       <p:sp>
         <p:nvSpPr>
@@ -1441,7 +1292,7 @@
           <a:bodyPr wrap="square" lIns="0" tIns="0" rIns="0" bIns="0" rtlCol="0" anchor="ctr"/>
           <a:lstStyle/>
           <a:p>
-            <a:pPr algn="ctr" indent="0" marL="0">
+            <a:pPr marL="0" indent="0" algn="ctr">
               <a:buNone/>
             </a:pPr>
             <a:r>
@@ -1485,6 +1336,13 @@
             <a:prstDash val="solid"/>
           </a:ln>
         </p:spPr>
+        <p:txBody>
+          <a:bodyPr/>
+          <a:lstStyle/>
+          <a:p>
+            <a:endParaRPr lang="en-US"/>
+          </a:p>
+        </p:txBody>
       </p:sp>
       <p:sp>
         <p:nvSpPr>
@@ -1507,7 +1365,7 @@
           <a:bodyPr wrap="square" lIns="0" tIns="0" rIns="0" bIns="0" rtlCol="0" anchor="ctr"/>
           <a:lstStyle/>
           <a:p>
-            <a:pPr algn="ctr" indent="0" marL="0">
+            <a:pPr marL="0" indent="0" algn="ctr">
               <a:buNone/>
             </a:pPr>
             <a:r>
@@ -1551,6 +1409,13 @@
             <a:prstDash val="solid"/>
           </a:ln>
         </p:spPr>
+        <p:txBody>
+          <a:bodyPr/>
+          <a:lstStyle/>
+          <a:p>
+            <a:endParaRPr lang="en-US"/>
+          </a:p>
+        </p:txBody>
       </p:sp>
       <p:sp>
         <p:nvSpPr>
@@ -1573,7 +1438,7 @@
           <a:bodyPr wrap="square" lIns="0" tIns="0" rIns="0" bIns="0" rtlCol="0" anchor="ctr"/>
           <a:lstStyle/>
           <a:p>
-            <a:pPr algn="ctr" indent="0" marL="0">
+            <a:pPr marL="0" indent="0" algn="ctr">
               <a:buNone/>
             </a:pPr>
             <a:r>
@@ -1612,13 +1477,20 @@
           </a:solidFill>
           <a:ln/>
           <a:effectLst>
-            <a:outerShdw sx="100000" sy="100000" kx="0" ky="0" algn="bl" rotWithShape="0" blurRad="127000" dist="38100" dir="5400000">
+            <a:outerShdw blurRad="127000" dist="38100" dir="5400000" algn="bl" rotWithShape="0">
               <a:srgbClr val="8A94A6">
                 <a:alpha val="35000"/>
               </a:srgbClr>
             </a:outerShdw>
           </a:effectLst>
         </p:spPr>
+        <p:txBody>
+          <a:bodyPr/>
+          <a:lstStyle/>
+          <a:p>
+            <a:endParaRPr lang="en-US"/>
+          </a:p>
+        </p:txBody>
       </p:sp>
       <p:sp>
         <p:nvSpPr>
@@ -1641,7 +1513,7 @@
           <a:bodyPr wrap="square" lIns="0" tIns="0" rIns="0" bIns="0" rtlCol="0" anchor="ctr"/>
           <a:lstStyle/>
           <a:p>
-            <a:pPr indent="0" marL="0">
+            <a:pPr marL="0" indent="0">
               <a:buNone/>
             </a:pPr>
             <a:r>
@@ -1680,6 +1552,13 @@
           </a:solidFill>
           <a:ln/>
         </p:spPr>
+        <p:txBody>
+          <a:bodyPr/>
+          <a:lstStyle/>
+          <a:p>
+            <a:endParaRPr lang="en-US"/>
+          </a:p>
+        </p:txBody>
       </p:sp>
       <p:sp>
         <p:nvSpPr>
@@ -1702,7 +1581,7 @@
           <a:bodyPr wrap="square" lIns="0" tIns="0" rIns="0" bIns="0" rtlCol="0" anchor="ctr"/>
           <a:lstStyle/>
           <a:p>
-            <a:pPr algn="ctr" indent="0" marL="0">
+            <a:pPr marL="0" indent="0" algn="ctr">
               <a:buNone/>
             </a:pPr>
             <a:r>
@@ -1741,7 +1620,7 @@
           <a:bodyPr wrap="square" lIns="0" tIns="0" rIns="0" bIns="0" rtlCol="0" anchor="ctr"/>
           <a:lstStyle/>
           <a:p>
-            <a:pPr indent="0" marL="0">
+            <a:pPr marL="0" indent="0">
               <a:buNone/>
             </a:pPr>
             <a:r>
@@ -1775,6 +1654,7 @@
         <a:solidFill>
           <a:srgbClr val="FFFFFF"/>
         </a:solidFill>
+        <a:effectLst/>
       </p:bgPr>
     </p:bg>
     <p:spTree>
@@ -1812,7 +1692,7 @@
           <a:bodyPr wrap="square" lIns="0" tIns="0" rIns="0" bIns="0" rtlCol="0" anchor="ctr"/>
           <a:lstStyle/>
           <a:p>
-            <a:pPr indent="0" marL="0">
+            <a:pPr marL="0" indent="0">
               <a:buNone/>
             </a:pPr>
             <a:r>
@@ -1851,7 +1731,7 @@
           <a:bodyPr wrap="square" lIns="0" tIns="0" rIns="0" bIns="0" rtlCol="0" anchor="ctr"/>
           <a:lstStyle/>
           <a:p>
-            <a:pPr indent="0" marL="0">
+            <a:pPr marL="0" indent="0">
               <a:buNone/>
             </a:pPr>
             <a:r>
@@ -1895,13 +1775,20 @@
             <a:prstDash val="solid"/>
           </a:ln>
           <a:effectLst>
-            <a:outerShdw sx="100000" sy="100000" kx="0" ky="0" algn="bl" rotWithShape="0" blurRad="127000" dist="38100" dir="5400000">
+            <a:outerShdw blurRad="127000" dist="38100" dir="5400000" algn="bl" rotWithShape="0">
               <a:srgbClr val="8A94A6">
                 <a:alpha val="35000"/>
               </a:srgbClr>
             </a:outerShdw>
           </a:effectLst>
         </p:spPr>
+        <p:txBody>
+          <a:bodyPr/>
+          <a:lstStyle/>
+          <a:p>
+            <a:endParaRPr lang="en-US"/>
+          </a:p>
+        </p:txBody>
       </p:sp>
       <p:sp>
         <p:nvSpPr>
@@ -1922,6 +1809,13 @@
           </a:solidFill>
           <a:ln/>
         </p:spPr>
+        <p:txBody>
+          <a:bodyPr/>
+          <a:lstStyle/>
+          <a:p>
+            <a:endParaRPr lang="en-US"/>
+          </a:p>
+        </p:txBody>
       </p:sp>
       <p:sp>
         <p:nvSpPr>
@@ -1944,7 +1838,7 @@
           <a:bodyPr wrap="square" lIns="0" tIns="0" rIns="0" bIns="0" rtlCol="0" anchor="t"/>
           <a:lstStyle/>
           <a:p>
-            <a:pPr indent="0" marL="0">
+            <a:pPr marL="0" indent="0">
               <a:lnSpc>
                 <a:spcPct val="95000"/>
               </a:lnSpc>
@@ -1986,7 +1880,7 @@
           <a:bodyPr wrap="square" lIns="0" tIns="0" rIns="0" bIns="0" rtlCol="0" anchor="t"/>
           <a:lstStyle/>
           <a:p>
-            <a:pPr indent="0" marL="0">
+            <a:pPr marL="0" indent="0">
               <a:lnSpc>
                 <a:spcPct val="102000"/>
               </a:lnSpc>
@@ -2033,13 +1927,20 @@
             <a:prstDash val="solid"/>
           </a:ln>
           <a:effectLst>
-            <a:outerShdw sx="100000" sy="100000" kx="0" ky="0" algn="bl" rotWithShape="0" blurRad="127000" dist="38100" dir="5400000">
+            <a:outerShdw blurRad="127000" dist="38100" dir="5400000" algn="bl" rotWithShape="0">
               <a:srgbClr val="8A94A6">
                 <a:alpha val="35000"/>
               </a:srgbClr>
             </a:outerShdw>
           </a:effectLst>
         </p:spPr>
+        <p:txBody>
+          <a:bodyPr/>
+          <a:lstStyle/>
+          <a:p>
+            <a:endParaRPr lang="en-US"/>
+          </a:p>
+        </p:txBody>
       </p:sp>
       <p:sp>
         <p:nvSpPr>
@@ -2060,6 +1961,13 @@
           </a:solidFill>
           <a:ln/>
         </p:spPr>
+        <p:txBody>
+          <a:bodyPr/>
+          <a:lstStyle/>
+          <a:p>
+            <a:endParaRPr lang="en-US"/>
+          </a:p>
+        </p:txBody>
       </p:sp>
       <p:sp>
         <p:nvSpPr>
@@ -2082,7 +1990,7 @@
           <a:bodyPr wrap="square" lIns="0" tIns="0" rIns="0" bIns="0" rtlCol="0" anchor="t"/>
           <a:lstStyle/>
           <a:p>
-            <a:pPr indent="0" marL="0">
+            <a:pPr marL="0" indent="0">
               <a:lnSpc>
                 <a:spcPct val="95000"/>
               </a:lnSpc>
@@ -2102,7 +2010,7 @@
             <a:endParaRPr lang="en-US" sz="3300" dirty="0"/>
           </a:p>
           <a:p>
-            <a:pPr indent="0" marL="0">
+            <a:pPr marL="0" indent="0">
               <a:lnSpc>
                 <a:spcPct val="95000"/>
               </a:lnSpc>
@@ -2144,7 +2052,7 @@
           <a:bodyPr wrap="square" lIns="0" tIns="0" rIns="0" bIns="0" rtlCol="0" anchor="t"/>
           <a:lstStyle/>
           <a:p>
-            <a:pPr indent="0" marL="0">
+            <a:pPr marL="0" indent="0">
               <a:lnSpc>
                 <a:spcPct val="102000"/>
               </a:lnSpc>
@@ -2191,13 +2099,20 @@
             <a:prstDash val="solid"/>
           </a:ln>
           <a:effectLst>
-            <a:outerShdw sx="100000" sy="100000" kx="0" ky="0" algn="bl" rotWithShape="0" blurRad="127000" dist="38100" dir="5400000">
+            <a:outerShdw blurRad="127000" dist="38100" dir="5400000" algn="bl" rotWithShape="0">
               <a:srgbClr val="8A94A6">
                 <a:alpha val="35000"/>
               </a:srgbClr>
             </a:outerShdw>
           </a:effectLst>
         </p:spPr>
+        <p:txBody>
+          <a:bodyPr/>
+          <a:lstStyle/>
+          <a:p>
+            <a:endParaRPr lang="en-US"/>
+          </a:p>
+        </p:txBody>
       </p:sp>
       <p:sp>
         <p:nvSpPr>
@@ -2218,6 +2133,13 @@
           </a:solidFill>
           <a:ln/>
         </p:spPr>
+        <p:txBody>
+          <a:bodyPr/>
+          <a:lstStyle/>
+          <a:p>
+            <a:endParaRPr lang="en-US"/>
+          </a:p>
+        </p:txBody>
       </p:sp>
       <p:sp>
         <p:nvSpPr>
@@ -2240,7 +2162,7 @@
           <a:bodyPr wrap="square" lIns="0" tIns="0" rIns="0" bIns="0" rtlCol="0" anchor="t"/>
           <a:lstStyle/>
           <a:p>
-            <a:pPr indent="0" marL="0">
+            <a:pPr marL="0" indent="0">
               <a:lnSpc>
                 <a:spcPct val="95000"/>
               </a:lnSpc>
@@ -2282,7 +2204,7 @@
           <a:bodyPr wrap="square" lIns="0" tIns="0" rIns="0" bIns="0" rtlCol="0" anchor="t"/>
           <a:lstStyle/>
           <a:p>
-            <a:pPr indent="0" marL="0">
+            <a:pPr marL="0" indent="0">
               <a:lnSpc>
                 <a:spcPct val="102000"/>
               </a:lnSpc>
@@ -2324,6 +2246,13 @@
           </a:solidFill>
           <a:ln/>
         </p:spPr>
+        <p:txBody>
+          <a:bodyPr/>
+          <a:lstStyle/>
+          <a:p>
+            <a:endParaRPr lang="en-US"/>
+          </a:p>
+        </p:txBody>
       </p:sp>
       <p:sp>
         <p:nvSpPr>
@@ -2346,7 +2275,7 @@
           <a:bodyPr wrap="square" lIns="0" tIns="0" rIns="0" bIns="0" rtlCol="0" anchor="ctr"/>
           <a:lstStyle/>
           <a:p>
-            <a:pPr indent="0" marL="0">
+            <a:pPr marL="0" indent="0">
               <a:lnSpc>
                 <a:spcPct val="105000"/>
               </a:lnSpc>
@@ -2383,6 +2312,7 @@
         <a:solidFill>
           <a:srgbClr val="FFFFFF"/>
         </a:solidFill>
+        <a:effectLst/>
       </p:bgPr>
     </p:bg>
     <p:spTree>
@@ -2420,7 +2350,7 @@
           <a:bodyPr wrap="square" lIns="0" tIns="0" rIns="0" bIns="0" rtlCol="0" anchor="ctr"/>
           <a:lstStyle/>
           <a:p>
-            <a:pPr indent="0" marL="0">
+            <a:pPr marL="0" indent="0">
               <a:buNone/>
             </a:pPr>
             <a:r>
@@ -2464,13 +2394,20 @@
             <a:prstDash val="solid"/>
           </a:ln>
           <a:effectLst>
-            <a:outerShdw sx="100000" sy="100000" kx="0" ky="0" algn="bl" rotWithShape="0" blurRad="127000" dist="38100" dir="5400000">
+            <a:outerShdw blurRad="127000" dist="38100" dir="5400000" algn="bl" rotWithShape="0">
               <a:srgbClr val="8A94A6">
                 <a:alpha val="35000"/>
               </a:srgbClr>
             </a:outerShdw>
           </a:effectLst>
         </p:spPr>
+        <p:txBody>
+          <a:bodyPr/>
+          <a:lstStyle/>
+          <a:p>
+            <a:endParaRPr lang="en-US"/>
+          </a:p>
+        </p:txBody>
       </p:sp>
       <p:sp>
         <p:nvSpPr>
@@ -2491,6 +2428,13 @@
           </a:solidFill>
           <a:ln/>
         </p:spPr>
+        <p:txBody>
+          <a:bodyPr/>
+          <a:lstStyle/>
+          <a:p>
+            <a:endParaRPr lang="en-US"/>
+          </a:p>
+        </p:txBody>
       </p:sp>
       <p:sp>
         <p:nvSpPr>
@@ -2513,7 +2457,7 @@
           <a:bodyPr wrap="square" lIns="0" tIns="0" rIns="0" bIns="0" rtlCol="0" anchor="ctr"/>
           <a:lstStyle/>
           <a:p>
-            <a:pPr algn="ctr" indent="0" marL="0">
+            <a:pPr marL="0" indent="0" algn="ctr">
               <a:buNone/>
             </a:pPr>
             <a:r>
@@ -2552,7 +2496,7 @@
           <a:bodyPr wrap="square" lIns="0" tIns="0" rIns="0" bIns="0" rtlCol="0" anchor="t"/>
           <a:lstStyle/>
           <a:p>
-            <a:pPr indent="0" marL="0">
+            <a:pPr marL="0" indent="0">
               <a:lnSpc>
                 <a:spcPct val="100000"/>
               </a:lnSpc>
@@ -2594,7 +2538,7 @@
           <a:bodyPr wrap="square" lIns="0" tIns="0" rIns="0" bIns="0" rtlCol="0" anchor="t"/>
           <a:lstStyle/>
           <a:p>
-            <a:pPr indent="0" marL="0">
+            <a:pPr marL="0" indent="0">
               <a:lnSpc>
                 <a:spcPct val="105000"/>
               </a:lnSpc>
@@ -2636,7 +2580,7 @@
           <a:bodyPr wrap="square" lIns="0" tIns="0" rIns="0" bIns="0" rtlCol="0" anchor="ctr"/>
           <a:lstStyle/>
           <a:p>
-            <a:pPr algn="ctr" indent="0" marL="0">
+            <a:pPr marL="0" indent="0" algn="ctr">
               <a:buNone/>
             </a:pPr>
             <a:r>
@@ -2680,13 +2624,20 @@
             <a:prstDash val="solid"/>
           </a:ln>
           <a:effectLst>
-            <a:outerShdw sx="100000" sy="100000" kx="0" ky="0" algn="bl" rotWithShape="0" blurRad="127000" dist="38100" dir="5400000">
+            <a:outerShdw blurRad="127000" dist="38100" dir="5400000" algn="bl" rotWithShape="0">
               <a:srgbClr val="8A94A6">
                 <a:alpha val="35000"/>
               </a:srgbClr>
             </a:outerShdw>
           </a:effectLst>
         </p:spPr>
+        <p:txBody>
+          <a:bodyPr/>
+          <a:lstStyle/>
+          <a:p>
+            <a:endParaRPr lang="en-US"/>
+          </a:p>
+        </p:txBody>
       </p:sp>
       <p:sp>
         <p:nvSpPr>
@@ -2707,6 +2658,13 @@
           </a:solidFill>
           <a:ln/>
         </p:spPr>
+        <p:txBody>
+          <a:bodyPr/>
+          <a:lstStyle/>
+          <a:p>
+            <a:endParaRPr lang="en-US"/>
+          </a:p>
+        </p:txBody>
       </p:sp>
       <p:sp>
         <p:nvSpPr>
@@ -2729,7 +2687,7 @@
           <a:bodyPr wrap="square" lIns="0" tIns="0" rIns="0" bIns="0" rtlCol="0" anchor="ctr"/>
           <a:lstStyle/>
           <a:p>
-            <a:pPr algn="ctr" indent="0" marL="0">
+            <a:pPr marL="0" indent="0" algn="ctr">
               <a:buNone/>
             </a:pPr>
             <a:r>
@@ -2768,7 +2726,7 @@
           <a:bodyPr wrap="square" lIns="0" tIns="0" rIns="0" bIns="0" rtlCol="0" anchor="t"/>
           <a:lstStyle/>
           <a:p>
-            <a:pPr indent="0" marL="0">
+            <a:pPr marL="0" indent="0">
               <a:lnSpc>
                 <a:spcPct val="100000"/>
               </a:lnSpc>
@@ -2810,7 +2768,7 @@
           <a:bodyPr wrap="square" lIns="0" tIns="0" rIns="0" bIns="0" rtlCol="0" anchor="t"/>
           <a:lstStyle/>
           <a:p>
-            <a:pPr indent="0" marL="0">
+            <a:pPr marL="0" indent="0">
               <a:lnSpc>
                 <a:spcPct val="105000"/>
               </a:lnSpc>
@@ -2852,7 +2810,7 @@
           <a:bodyPr wrap="square" lIns="0" tIns="0" rIns="0" bIns="0" rtlCol="0" anchor="ctr"/>
           <a:lstStyle/>
           <a:p>
-            <a:pPr algn="ctr" indent="0" marL="0">
+            <a:pPr marL="0" indent="0" algn="ctr">
               <a:buNone/>
             </a:pPr>
             <a:r>
@@ -2896,13 +2854,20 @@
             <a:prstDash val="solid"/>
           </a:ln>
           <a:effectLst>
-            <a:outerShdw sx="100000" sy="100000" kx="0" ky="0" algn="bl" rotWithShape="0" blurRad="127000" dist="38100" dir="5400000">
+            <a:outerShdw blurRad="127000" dist="38100" dir="5400000" algn="bl" rotWithShape="0">
               <a:srgbClr val="8A94A6">
                 <a:alpha val="35000"/>
               </a:srgbClr>
             </a:outerShdw>
           </a:effectLst>
         </p:spPr>
+        <p:txBody>
+          <a:bodyPr/>
+          <a:lstStyle/>
+          <a:p>
+            <a:endParaRPr lang="en-US"/>
+          </a:p>
+        </p:txBody>
       </p:sp>
       <p:sp>
         <p:nvSpPr>
@@ -2923,6 +2888,13 @@
           </a:solidFill>
           <a:ln/>
         </p:spPr>
+        <p:txBody>
+          <a:bodyPr/>
+          <a:lstStyle/>
+          <a:p>
+            <a:endParaRPr lang="en-US"/>
+          </a:p>
+        </p:txBody>
       </p:sp>
       <p:sp>
         <p:nvSpPr>
@@ -2945,7 +2917,7 @@
           <a:bodyPr wrap="square" lIns="0" tIns="0" rIns="0" bIns="0" rtlCol="0" anchor="ctr"/>
           <a:lstStyle/>
           <a:p>
-            <a:pPr algn="ctr" indent="0" marL="0">
+            <a:pPr marL="0" indent="0" algn="ctr">
               <a:buNone/>
             </a:pPr>
             <a:r>
@@ -2984,7 +2956,7 @@
           <a:bodyPr wrap="square" lIns="0" tIns="0" rIns="0" bIns="0" rtlCol="0" anchor="t"/>
           <a:lstStyle/>
           <a:p>
-            <a:pPr indent="0" marL="0">
+            <a:pPr marL="0" indent="0">
               <a:lnSpc>
                 <a:spcPct val="100000"/>
               </a:lnSpc>
@@ -3026,7 +2998,7 @@
           <a:bodyPr wrap="square" lIns="0" tIns="0" rIns="0" bIns="0" rtlCol="0" anchor="t"/>
           <a:lstStyle/>
           <a:p>
-            <a:pPr indent="0" marL="0">
+            <a:pPr marL="0" indent="0">
               <a:lnSpc>
                 <a:spcPct val="105000"/>
               </a:lnSpc>
@@ -3068,7 +3040,7 @@
           <a:bodyPr wrap="square" lIns="0" tIns="0" rIns="0" bIns="0" rtlCol="0" anchor="ctr"/>
           <a:lstStyle/>
           <a:p>
-            <a:pPr algn="ctr" indent="0" marL="0">
+            <a:pPr marL="0" indent="0" algn="ctr">
               <a:buNone/>
             </a:pPr>
             <a:r>
@@ -3112,13 +3084,20 @@
             <a:prstDash val="solid"/>
           </a:ln>
           <a:effectLst>
-            <a:outerShdw sx="100000" sy="100000" kx="0" ky="0" algn="bl" rotWithShape="0" blurRad="127000" dist="38100" dir="5400000">
+            <a:outerShdw blurRad="127000" dist="38100" dir="5400000" algn="bl" rotWithShape="0">
               <a:srgbClr val="8A94A6">
                 <a:alpha val="35000"/>
               </a:srgbClr>
             </a:outerShdw>
           </a:effectLst>
         </p:spPr>
+        <p:txBody>
+          <a:bodyPr/>
+          <a:lstStyle/>
+          <a:p>
+            <a:endParaRPr lang="en-US"/>
+          </a:p>
+        </p:txBody>
       </p:sp>
       <p:sp>
         <p:nvSpPr>
@@ -3139,6 +3118,13 @@
           </a:solidFill>
           <a:ln/>
         </p:spPr>
+        <p:txBody>
+          <a:bodyPr/>
+          <a:lstStyle/>
+          <a:p>
+            <a:endParaRPr lang="en-US"/>
+          </a:p>
+        </p:txBody>
       </p:sp>
       <p:sp>
         <p:nvSpPr>
@@ -3161,7 +3147,7 @@
           <a:bodyPr wrap="square" lIns="0" tIns="0" rIns="0" bIns="0" rtlCol="0" anchor="ctr"/>
           <a:lstStyle/>
           <a:p>
-            <a:pPr algn="ctr" indent="0" marL="0">
+            <a:pPr marL="0" indent="0" algn="ctr">
               <a:buNone/>
             </a:pPr>
             <a:r>
@@ -3200,7 +3186,7 @@
           <a:bodyPr wrap="square" lIns="0" tIns="0" rIns="0" bIns="0" rtlCol="0" anchor="t"/>
           <a:lstStyle/>
           <a:p>
-            <a:pPr indent="0" marL="0">
+            <a:pPr marL="0" indent="0">
               <a:lnSpc>
                 <a:spcPct val="100000"/>
               </a:lnSpc>
@@ -3242,7 +3228,7 @@
           <a:bodyPr wrap="square" lIns="0" tIns="0" rIns="0" bIns="0" rtlCol="0" anchor="t"/>
           <a:lstStyle/>
           <a:p>
-            <a:pPr indent="0" marL="0">
+            <a:pPr marL="0" indent="0">
               <a:lnSpc>
                 <a:spcPct val="105000"/>
               </a:lnSpc>
@@ -3289,6 +3275,13 @@
             <a:prstDash val="solid"/>
           </a:ln>
         </p:spPr>
+        <p:txBody>
+          <a:bodyPr/>
+          <a:lstStyle/>
+          <a:p>
+            <a:endParaRPr lang="en-US"/>
+          </a:p>
+        </p:txBody>
       </p:sp>
       <p:sp>
         <p:nvSpPr>
@@ -3309,6 +3302,13 @@
           </a:solidFill>
           <a:ln/>
         </p:spPr>
+        <p:txBody>
+          <a:bodyPr/>
+          <a:lstStyle/>
+          <a:p>
+            <a:endParaRPr lang="en-US"/>
+          </a:p>
+        </p:txBody>
       </p:sp>
       <p:sp>
         <p:nvSpPr>
@@ -3331,7 +3331,7 @@
           <a:bodyPr wrap="square" lIns="0" tIns="0" rIns="0" bIns="0" rtlCol="0" anchor="ctr"/>
           <a:lstStyle/>
           <a:p>
-            <a:pPr algn="ctr" indent="0" marL="0">
+            <a:pPr marL="0" indent="0" algn="ctr">
               <a:buNone/>
             </a:pPr>
             <a:r>
@@ -3370,7 +3370,7 @@
           <a:bodyPr wrap="square" lIns="0" tIns="0" rIns="0" bIns="0" rtlCol="0" anchor="ctr"/>
           <a:lstStyle/>
           <a:p>
-            <a:pPr indent="0" marL="0">
+            <a:pPr marL="0" indent="0">
               <a:lnSpc>
                 <a:spcPct val="108000"/>
               </a:lnSpc>
@@ -3387,12 +3387,6 @@
               </a:rPr>
               <a:t>The AI is deterministic, local, and inspectable.</a:t>
             </a:r>
-            <a:pPr indent="0" marL="0">
-              <a:lnSpc>
-                <a:spcPct val="108000"/>
-              </a:lnSpc>
-              <a:buNone/>
-            </a:pPr>
             <a:r>
               <a:rPr lang="en-US" sz="1500" dirty="0">
                 <a:solidFill>
@@ -3424,6 +3418,7 @@
         <a:solidFill>
           <a:srgbClr val="FFFFFF"/>
         </a:solidFill>
+        <a:effectLst/>
       </p:bgPr>
     </p:bg>
     <p:spTree>
@@ -3461,7 +3456,7 @@
           <a:bodyPr wrap="square" lIns="0" tIns="0" rIns="0" bIns="0" rtlCol="0" anchor="ctr"/>
           <a:lstStyle/>
           <a:p>
-            <a:pPr indent="0" marL="0">
+            <a:pPr marL="0" indent="0">
               <a:buNone/>
             </a:pPr>
             <a:r>
@@ -3500,7 +3495,7 @@
           <a:bodyPr wrap="square" lIns="0" tIns="0" rIns="0" bIns="0" rtlCol="0" anchor="ctr"/>
           <a:lstStyle/>
           <a:p>
-            <a:pPr indent="0" marL="0">
+            <a:pPr marL="0" indent="0">
               <a:buNone/>
             </a:pPr>
             <a:r>
@@ -3544,13 +3539,20 @@
             <a:prstDash val="solid"/>
           </a:ln>
           <a:effectLst>
-            <a:outerShdw sx="100000" sy="100000" kx="0" ky="0" algn="bl" rotWithShape="0" blurRad="127000" dist="38100" dir="5400000">
+            <a:outerShdw blurRad="127000" dist="38100" dir="5400000" algn="bl" rotWithShape="0">
               <a:srgbClr val="8A94A6">
                 <a:alpha val="35000"/>
               </a:srgbClr>
             </a:outerShdw>
           </a:effectLst>
         </p:spPr>
+        <p:txBody>
+          <a:bodyPr/>
+          <a:lstStyle/>
+          <a:p>
+            <a:endParaRPr lang="en-US"/>
+          </a:p>
+        </p:txBody>
       </p:sp>
       <p:sp>
         <p:nvSpPr>
@@ -3571,6 +3573,13 @@
           </a:solidFill>
           <a:ln/>
         </p:spPr>
+        <p:txBody>
+          <a:bodyPr/>
+          <a:lstStyle/>
+          <a:p>
+            <a:endParaRPr lang="en-US"/>
+          </a:p>
+        </p:txBody>
       </p:sp>
       <p:sp>
         <p:nvSpPr>
@@ -3593,7 +3602,7 @@
           <a:bodyPr wrap="square" lIns="0" tIns="0" rIns="0" bIns="0" rtlCol="0" anchor="ctr"/>
           <a:lstStyle/>
           <a:p>
-            <a:pPr indent="0" marL="0">
+            <a:pPr marL="0" indent="0">
               <a:buNone/>
             </a:pPr>
             <a:r>
@@ -3632,7 +3641,7 @@
           <a:bodyPr wrap="square" lIns="0" tIns="0" rIns="0" bIns="0" rtlCol="0" anchor="t"/>
           <a:lstStyle/>
           <a:p>
-            <a:pPr indent="0" marL="0">
+            <a:pPr marL="0" indent="0">
               <a:lnSpc>
                 <a:spcPct val="104000"/>
               </a:lnSpc>
@@ -3679,13 +3688,20 @@
             <a:prstDash val="solid"/>
           </a:ln>
           <a:effectLst>
-            <a:outerShdw sx="100000" sy="100000" kx="0" ky="0" algn="bl" rotWithShape="0" blurRad="127000" dist="38100" dir="5400000">
+            <a:outerShdw blurRad="127000" dist="38100" dir="5400000" algn="bl" rotWithShape="0">
               <a:srgbClr val="8A94A6">
                 <a:alpha val="35000"/>
               </a:srgbClr>
             </a:outerShdw>
           </a:effectLst>
         </p:spPr>
+        <p:txBody>
+          <a:bodyPr/>
+          <a:lstStyle/>
+          <a:p>
+            <a:endParaRPr lang="en-US"/>
+          </a:p>
+        </p:txBody>
       </p:sp>
       <p:sp>
         <p:nvSpPr>
@@ -3706,6 +3722,13 @@
           </a:solidFill>
           <a:ln/>
         </p:spPr>
+        <p:txBody>
+          <a:bodyPr/>
+          <a:lstStyle/>
+          <a:p>
+            <a:endParaRPr lang="en-US"/>
+          </a:p>
+        </p:txBody>
       </p:sp>
       <p:sp>
         <p:nvSpPr>
@@ -3728,7 +3751,7 @@
           <a:bodyPr wrap="square" lIns="0" tIns="0" rIns="0" bIns="0" rtlCol="0" anchor="ctr"/>
           <a:lstStyle/>
           <a:p>
-            <a:pPr indent="0" marL="0">
+            <a:pPr marL="0" indent="0">
               <a:buNone/>
             </a:pPr>
             <a:r>
@@ -3767,7 +3790,7 @@
           <a:bodyPr wrap="square" lIns="0" tIns="0" rIns="0" bIns="0" rtlCol="0" anchor="t"/>
           <a:lstStyle/>
           <a:p>
-            <a:pPr indent="0" marL="0">
+            <a:pPr marL="0" indent="0">
               <a:lnSpc>
                 <a:spcPct val="104000"/>
               </a:lnSpc>
@@ -3814,13 +3837,20 @@
             <a:prstDash val="solid"/>
           </a:ln>
           <a:effectLst>
-            <a:outerShdw sx="100000" sy="100000" kx="0" ky="0" algn="bl" rotWithShape="0" blurRad="127000" dist="38100" dir="5400000">
+            <a:outerShdw blurRad="127000" dist="38100" dir="5400000" algn="bl" rotWithShape="0">
               <a:srgbClr val="8A94A6">
                 <a:alpha val="35000"/>
               </a:srgbClr>
             </a:outerShdw>
           </a:effectLst>
         </p:spPr>
+        <p:txBody>
+          <a:bodyPr/>
+          <a:lstStyle/>
+          <a:p>
+            <a:endParaRPr lang="en-US"/>
+          </a:p>
+        </p:txBody>
       </p:sp>
       <p:sp>
         <p:nvSpPr>
@@ -3841,6 +3871,13 @@
           </a:solidFill>
           <a:ln/>
         </p:spPr>
+        <p:txBody>
+          <a:bodyPr/>
+          <a:lstStyle/>
+          <a:p>
+            <a:endParaRPr lang="en-US"/>
+          </a:p>
+        </p:txBody>
       </p:sp>
       <p:sp>
         <p:nvSpPr>
@@ -3863,7 +3900,7 @@
           <a:bodyPr wrap="square" lIns="0" tIns="0" rIns="0" bIns="0" rtlCol="0" anchor="ctr"/>
           <a:lstStyle/>
           <a:p>
-            <a:pPr indent="0" marL="0">
+            <a:pPr marL="0" indent="0">
               <a:buNone/>
             </a:pPr>
             <a:r>
@@ -3902,7 +3939,7 @@
           <a:bodyPr wrap="square" lIns="0" tIns="0" rIns="0" bIns="0" rtlCol="0" anchor="t"/>
           <a:lstStyle/>
           <a:p>
-            <a:pPr indent="0" marL="0">
+            <a:pPr marL="0" indent="0">
               <a:lnSpc>
                 <a:spcPct val="104000"/>
               </a:lnSpc>
@@ -3949,13 +3986,20 @@
             <a:prstDash val="solid"/>
           </a:ln>
           <a:effectLst>
-            <a:outerShdw sx="100000" sy="100000" kx="0" ky="0" algn="bl" rotWithShape="0" blurRad="127000" dist="38100" dir="5400000">
+            <a:outerShdw blurRad="127000" dist="38100" dir="5400000" algn="bl" rotWithShape="0">
               <a:srgbClr val="8A94A6">
                 <a:alpha val="35000"/>
               </a:srgbClr>
             </a:outerShdw>
           </a:effectLst>
         </p:spPr>
+        <p:txBody>
+          <a:bodyPr/>
+          <a:lstStyle/>
+          <a:p>
+            <a:endParaRPr lang="en-US"/>
+          </a:p>
+        </p:txBody>
       </p:sp>
       <p:sp>
         <p:nvSpPr>
@@ -3976,6 +4020,13 @@
           </a:solidFill>
           <a:ln/>
         </p:spPr>
+        <p:txBody>
+          <a:bodyPr/>
+          <a:lstStyle/>
+          <a:p>
+            <a:endParaRPr lang="en-US"/>
+          </a:p>
+        </p:txBody>
       </p:sp>
       <p:sp>
         <p:nvSpPr>
@@ -3998,7 +4049,7 @@
           <a:bodyPr wrap="square" lIns="0" tIns="0" rIns="0" bIns="0" rtlCol="0" anchor="ctr"/>
           <a:lstStyle/>
           <a:p>
-            <a:pPr indent="0" marL="0">
+            <a:pPr marL="0" indent="0">
               <a:buNone/>
             </a:pPr>
             <a:r>
@@ -4037,7 +4088,7 @@
           <a:bodyPr wrap="square" lIns="0" tIns="0" rIns="0" bIns="0" rtlCol="0" anchor="t"/>
           <a:lstStyle/>
           <a:p>
-            <a:pPr indent="0" marL="0">
+            <a:pPr marL="0" indent="0">
               <a:lnSpc>
                 <a:spcPct val="104000"/>
               </a:lnSpc>
@@ -4084,13 +4135,20 @@
             <a:prstDash val="solid"/>
           </a:ln>
           <a:effectLst>
-            <a:outerShdw sx="100000" sy="100000" kx="0" ky="0" algn="bl" rotWithShape="0" blurRad="127000" dist="38100" dir="5400000">
+            <a:outerShdw blurRad="127000" dist="38100" dir="5400000" algn="bl" rotWithShape="0">
               <a:srgbClr val="8A94A6">
                 <a:alpha val="35000"/>
               </a:srgbClr>
             </a:outerShdw>
           </a:effectLst>
         </p:spPr>
+        <p:txBody>
+          <a:bodyPr/>
+          <a:lstStyle/>
+          <a:p>
+            <a:endParaRPr lang="en-US"/>
+          </a:p>
+        </p:txBody>
       </p:sp>
       <p:sp>
         <p:nvSpPr>
@@ -4111,6 +4169,13 @@
           </a:solidFill>
           <a:ln/>
         </p:spPr>
+        <p:txBody>
+          <a:bodyPr/>
+          <a:lstStyle/>
+          <a:p>
+            <a:endParaRPr lang="en-US"/>
+          </a:p>
+        </p:txBody>
       </p:sp>
       <p:sp>
         <p:nvSpPr>
@@ -4133,7 +4198,7 @@
           <a:bodyPr wrap="square" lIns="0" tIns="0" rIns="0" bIns="0" rtlCol="0" anchor="ctr"/>
           <a:lstStyle/>
           <a:p>
-            <a:pPr indent="0" marL="0">
+            <a:pPr marL="0" indent="0">
               <a:buNone/>
             </a:pPr>
             <a:r>
@@ -4172,7 +4237,7 @@
           <a:bodyPr wrap="square" lIns="0" tIns="0" rIns="0" bIns="0" rtlCol="0" anchor="t"/>
           <a:lstStyle/>
           <a:p>
-            <a:pPr indent="0" marL="0">
+            <a:pPr marL="0" indent="0">
               <a:lnSpc>
                 <a:spcPct val="104000"/>
               </a:lnSpc>
@@ -4201,7 +4266,7 @@
         </p:nvSpPr>
         <p:spPr>
           <a:xfrm>
-            <a:off x="8180832" y="3886200"/>
+            <a:off x="8180832" y="3903156"/>
             <a:ext cx="3441192" cy="1737360"/>
           </a:xfrm>
           <a:prstGeom prst="roundRect">
@@ -4219,13 +4284,20 @@
             <a:prstDash val="solid"/>
           </a:ln>
           <a:effectLst>
-            <a:outerShdw sx="100000" sy="100000" kx="0" ky="0" algn="bl" rotWithShape="0" blurRad="127000" dist="38100" dir="5400000">
+            <a:outerShdw blurRad="127000" dist="38100" dir="5400000" algn="bl" rotWithShape="0">
               <a:srgbClr val="8A94A6">
                 <a:alpha val="35000"/>
               </a:srgbClr>
             </a:outerShdw>
           </a:effectLst>
         </p:spPr>
+        <p:txBody>
+          <a:bodyPr/>
+          <a:lstStyle/>
+          <a:p>
+            <a:endParaRPr lang="en-US" dirty="0"/>
+          </a:p>
+        </p:txBody>
       </p:sp>
       <p:sp>
         <p:nvSpPr>
@@ -4246,6 +4318,13 @@
           </a:solidFill>
           <a:ln/>
         </p:spPr>
+        <p:txBody>
+          <a:bodyPr/>
+          <a:lstStyle/>
+          <a:p>
+            <a:endParaRPr lang="en-US"/>
+          </a:p>
+        </p:txBody>
       </p:sp>
       <p:sp>
         <p:nvSpPr>
@@ -4268,11 +4347,73 @@
           <a:bodyPr wrap="square" lIns="0" tIns="0" rIns="0" bIns="0" rtlCol="0" anchor="ctr"/>
           <a:lstStyle/>
           <a:p>
-            <a:pPr indent="0" marL="0">
-              <a:buNone/>
-            </a:pPr>
-            <a:r>
-              <a:rPr lang="en-US" sz="1700" b="1" dirty="0">
+            <a:pPr marL="0" indent="0">
+              <a:buNone/>
+            </a:pPr>
+            <a:r>
+              <a:rPr lang="en-US" sz="1700" dirty="0"/>
+              <a:t>Freight Optimization ticketing system</a:t>
+            </a:r>
+          </a:p>
+        </p:txBody>
+      </p:sp>
+      <p:sp>
+        <p:nvSpPr>
+          <p:cNvPr id="27" name="Text 25"/>
+          <p:cNvSpPr/>
+          <p:nvPr/>
+        </p:nvSpPr>
+        <p:spPr>
+          <a:xfrm>
+            <a:off x="8473440" y="4680396"/>
+            <a:ext cx="2892552" cy="960120"/>
+          </a:xfrm>
+          <a:prstGeom prst="rect">
+            <a:avLst/>
+          </a:prstGeom>
+          <a:noFill/>
+          <a:ln/>
+        </p:spPr>
+        <p:txBody>
+          <a:bodyPr wrap="square" lIns="0" tIns="0" rIns="0" bIns="0" rtlCol="0" anchor="t"/>
+          <a:lstStyle/>
+          <a:p>
+            <a:pPr marL="0" indent="0">
+              <a:lnSpc>
+                <a:spcPct val="104000"/>
+              </a:lnSpc>
+              <a:buNone/>
+            </a:pPr>
+            <a:endParaRPr lang="en-US" sz="1250" dirty="0"/>
+          </a:p>
+        </p:txBody>
+      </p:sp>
+      <p:sp>
+        <p:nvSpPr>
+          <p:cNvPr id="28" name="Text 26"/>
+          <p:cNvSpPr/>
+          <p:nvPr/>
+        </p:nvSpPr>
+        <p:spPr>
+          <a:xfrm>
+            <a:off x="566928" y="6172200"/>
+            <a:ext cx="11055096" cy="365760"/>
+          </a:xfrm>
+          <a:prstGeom prst="rect">
+            <a:avLst/>
+          </a:prstGeom>
+          <a:noFill/>
+          <a:ln/>
+        </p:spPr>
+        <p:txBody>
+          <a:bodyPr wrap="square" lIns="0" tIns="0" rIns="0" bIns="0" rtlCol="0" anchor="ctr"/>
+          <a:lstStyle/>
+          <a:p>
+            <a:pPr marL="0" indent="0" algn="l">
+              <a:buNone/>
+            </a:pPr>
+            <a:r>
+              <a:rPr lang="en-US" sz="1300" b="1" dirty="0">
                 <a:solidFill>
                   <a:srgbClr val="1C2333"/>
                 </a:solidFill>
@@ -4280,21 +4421,38 @@
                 <a:ea typeface="Calibri" pitchFamily="34" charset="-122"/>
                 <a:cs typeface="Calibri" pitchFamily="34" charset="-120"/>
               </a:rPr>
-              <a:t>ServiceNow Transition</a:t>
-            </a:r>
-            <a:endParaRPr lang="en-US" sz="1700" dirty="0"/>
-          </a:p>
-        </p:txBody>
-      </p:sp>
-      <p:sp>
-        <p:nvSpPr>
-          <p:cNvPr id="27" name="Text 25"/>
-          <p:cNvSpPr/>
-          <p:nvPr/>
-        </p:nvSpPr>
-        <p:spPr>
-          <a:xfrm>
-            <a:off x="8455152" y="4544568"/>
+              <a:t>Dependency-free: </a:t>
+            </a:r>
+            <a:r>
+              <a:rPr lang="en-US" sz="1300" dirty="0">
+                <a:solidFill>
+                  <a:srgbClr val="5B6472"/>
+                </a:solidFill>
+                <a:latin typeface="Calibri" pitchFamily="34" charset="0"/>
+                <a:ea typeface="Calibri" pitchFamily="34" charset="-122"/>
+                <a:cs typeface="Calibri" pitchFamily="34" charset="-120"/>
+              </a:rPr>
+              <a:t>plain HTML/CSS/JS, shared localStorage state. No license, backend server, database, or package manager — just a small local static-file server to run it.</a:t>
+            </a:r>
+            <a:endParaRPr lang="en-US" sz="1300" dirty="0"/>
+          </a:p>
+        </p:txBody>
+      </p:sp>
+      <p:sp>
+        <p:nvSpPr>
+          <p:cNvPr id="31" name="Text 13">
+            <a:extLst>
+              <a:ext uri="{FF2B5EF4-FFF2-40B4-BE49-F238E27FC236}">
+                <a16:creationId xmlns:a16="http://schemas.microsoft.com/office/drawing/2014/main" id="{093D0421-6EB1-0EC6-99D9-DB74552CAC4E}"/>
+              </a:ext>
+            </a:extLst>
+          </p:cNvPr>
+          <p:cNvSpPr/>
+          <p:nvPr/>
+        </p:nvSpPr>
+        <p:spPr>
+          <a:xfrm>
+            <a:off x="8583168" y="4621626"/>
             <a:ext cx="2892552" cy="960120"/>
           </a:xfrm>
           <a:prstGeom prst="rect">
@@ -4307,77 +4465,21 @@
           <a:bodyPr wrap="square" lIns="0" tIns="0" rIns="0" bIns="0" rtlCol="0" anchor="t"/>
           <a:lstStyle/>
           <a:p>
-            <a:pPr indent="0" marL="0">
+            <a:pPr algn="ctr">
               <a:lnSpc>
                 <a:spcPct val="104000"/>
               </a:lnSpc>
-              <a:buNone/>
             </a:pPr>
             <a:r>
               <a:rPr lang="en-US" sz="1250" dirty="0">
                 <a:solidFill>
-                  <a:srgbClr val="5B6472"/>
-                </a:solidFill>
-                <a:latin typeface="Calibri" pitchFamily="34" charset="0"/>
-                <a:ea typeface="Calibri" pitchFamily="34" charset="-122"/>
-                <a:cs typeface="Calibri" pitchFamily="34" charset="-120"/>
-              </a:rPr>
-              <a:t>Modeled scope, field mapping, dry-run validation, and cutover / rollback.</a:t>
-            </a:r>
-            <a:endParaRPr lang="en-US" sz="1250" dirty="0"/>
-          </a:p>
-        </p:txBody>
-      </p:sp>
-      <p:sp>
-        <p:nvSpPr>
-          <p:cNvPr id="28" name="Text 26"/>
-          <p:cNvSpPr/>
-          <p:nvPr/>
-        </p:nvSpPr>
-        <p:spPr>
-          <a:xfrm>
-            <a:off x="566928" y="6172200"/>
-            <a:ext cx="11055096" cy="365760"/>
-          </a:xfrm>
-          <a:prstGeom prst="rect">
-            <a:avLst/>
-          </a:prstGeom>
-          <a:noFill/>
-          <a:ln/>
-        </p:spPr>
-        <p:txBody>
-          <a:bodyPr wrap="square" lIns="0" tIns="0" rIns="0" bIns="0" rtlCol="0" anchor="ctr"/>
-          <a:lstStyle/>
-          <a:p>
-            <a:pPr algn="l" indent="0" marL="0">
-              <a:buNone/>
-            </a:pPr>
-            <a:r>
-              <a:rPr lang="en-US" sz="1300" b="1" dirty="0">
-                <a:solidFill>
-                  <a:srgbClr val="1C2333"/>
-                </a:solidFill>
-                <a:latin typeface="Calibri" pitchFamily="34" charset="0"/>
-                <a:ea typeface="Calibri" pitchFamily="34" charset="-122"/>
-                <a:cs typeface="Calibri" pitchFamily="34" charset="-120"/>
-              </a:rPr>
-              <a:t>Dependency-free: </a:t>
-            </a:r>
-            <a:pPr algn="l" indent="0" marL="0">
-              <a:buNone/>
-            </a:pPr>
-            <a:r>
-              <a:rPr lang="en-US" sz="1300" dirty="0">
-                <a:solidFill>
-                  <a:srgbClr val="5B6472"/>
-                </a:solidFill>
-                <a:latin typeface="Calibri" pitchFamily="34" charset="0"/>
-                <a:ea typeface="Calibri" pitchFamily="34" charset="-122"/>
-                <a:cs typeface="Calibri" pitchFamily="34" charset="-120"/>
-              </a:rPr>
-              <a:t>plain HTML/CSS/JS, shared localStorage state. No license, backend server, database, or package manager — just a small local static-file server to run it.</a:t>
-            </a:r>
-            <a:endParaRPr lang="en-US" sz="1300" dirty="0"/>
+                  <a:schemeClr val="bg1">
+                    <a:lumMod val="50000"/>
+                  </a:schemeClr>
+                </a:solidFill>
+              </a:rPr>
+              <a:t>Analyzes outbound shipments to identify consolidation opportunities, reduce freight costs, and support consistent, policy-driven transportation decisions.</a:t>
+            </a:r>
           </a:p>
         </p:txBody>
       </p:sp>
@@ -4397,6 +4499,7 @@
         <a:solidFill>
           <a:srgbClr val="16224A"/>
         </a:solidFill>
+        <a:effectLst/>
       </p:bgPr>
     </p:bg>
     <p:spTree>
@@ -4432,6 +4535,13 @@
           </a:solidFill>
           <a:ln/>
         </p:spPr>
+        <p:txBody>
+          <a:bodyPr/>
+          <a:lstStyle/>
+          <a:p>
+            <a:endParaRPr lang="en-US"/>
+          </a:p>
+        </p:txBody>
       </p:sp>
       <p:sp>
         <p:nvSpPr>
@@ -4454,7 +4564,7 @@
           <a:bodyPr wrap="square" lIns="0" tIns="0" rIns="0" bIns="0" rtlCol="0" anchor="ctr"/>
           <a:lstStyle/>
           <a:p>
-            <a:pPr indent="0" marL="0">
+            <a:pPr marL="0" indent="0">
               <a:buNone/>
             </a:pPr>
             <a:r>
@@ -4493,11 +4603,11 @@
           <a:bodyPr wrap="square" lIns="0" tIns="0" rIns="0" bIns="0" rtlCol="0" anchor="ctr"/>
           <a:lstStyle/>
           <a:p>
-            <a:pPr indent="0" marL="0">
-              <a:buNone/>
-            </a:pPr>
-            <a:r>
-              <a:rPr lang="en-US" sz="1300" b="1" spc="200" kern="0" dirty="0">
+            <a:pPr marL="0" indent="0">
+              <a:buNone/>
+            </a:pPr>
+            <a:r>
+              <a:rPr lang="en-US" sz="1300" b="1" kern="0" spc="200" dirty="0">
                 <a:solidFill>
                   <a:srgbClr val="CADCFC"/>
                 </a:solidFill>
@@ -4532,7 +4642,7 @@
           <a:bodyPr wrap="square" lIns="0" tIns="0" rIns="0" bIns="0" rtlCol="0" anchor="ctr"/>
           <a:lstStyle/>
           <a:p>
-            <a:pPr indent="0" marL="0">
+            <a:pPr marL="0" indent="0">
               <a:buNone/>
             </a:pPr>
             <a:r>
@@ -4571,7 +4681,7 @@
           <a:bodyPr wrap="square" lIns="0" tIns="0" rIns="0" bIns="0" rtlCol="0" anchor="ctr"/>
           <a:lstStyle/>
           <a:p>
-            <a:pPr indent="0" marL="0">
+            <a:pPr marL="0" indent="0">
               <a:buNone/>
             </a:pPr>
             <a:r>
@@ -4623,15 +4733,14 @@
             <a:r>
               <a:rPr lang="en-US" sz="1450" dirty="0">
                 <a:solidFill>
-                  <a:srgbClr val="FFFFFF"/>
+                  <a:schemeClr val="bg1"/>
                 </a:solidFill>
                 <a:latin typeface="Calibri" pitchFamily="34" charset="0"/>
                 <a:ea typeface="Calibri" pitchFamily="34" charset="-122"/>
                 <a:cs typeface="Calibri" pitchFamily="34" charset="-120"/>
               </a:rPr>
-              <a:t>All 12 Problem #4 requirements demonstrable end-to-end</a:t>
-            </a:r>
-            <a:endParaRPr lang="en-US" sz="1450" dirty="0"/>
+              <a:t>AI-assisted request intake improves ticket quality before work begins </a:t>
+            </a:r>
           </a:p>
           <a:p>
             <a:pPr marL="203200" indent="-203200">
@@ -4645,17 +4754,13 @@
               <a:buChar char="•"/>
             </a:pPr>
             <a:r>
-              <a:rPr lang="en-US" sz="1450" dirty="0">
-                <a:solidFill>
-                  <a:srgbClr val="FFFFFF"/>
-                </a:solidFill>
-                <a:latin typeface="Calibri" pitchFamily="34" charset="0"/>
-                <a:ea typeface="Calibri" pitchFamily="34" charset="-122"/>
-                <a:cs typeface="Calibri" pitchFamily="34" charset="-120"/>
-              </a:rPr>
-              <a:t>Zero dependencies, zero new licenses to run</a:t>
-            </a:r>
-            <a:endParaRPr lang="en-US" sz="1450" dirty="0"/>
+              <a:rPr lang="en-US" sz="1600" dirty="0">
+                <a:solidFill>
+                  <a:schemeClr val="bg1"/>
+                </a:solidFill>
+              </a:rPr>
+              <a:t>Intelligent routing reduces manual triage and rework Demonstrates all Problem #4 Ticketing System Replacement requirements </a:t>
+            </a:r>
           </a:p>
           <a:p>
             <a:pPr marL="203200" indent="-203200">
@@ -4669,17 +4774,13 @@
               <a:buChar char="•"/>
             </a:pPr>
             <a:r>
-              <a:rPr lang="en-US" sz="1450" dirty="0">
-                <a:solidFill>
-                  <a:srgbClr val="FFFFFF"/>
-                </a:solidFill>
-                <a:latin typeface="Calibri" pitchFamily="34" charset="0"/>
-                <a:ea typeface="Calibri" pitchFamily="34" charset="-122"/>
-                <a:cs typeface="Calibri" pitchFamily="34" charset="-120"/>
-              </a:rPr>
-              <a:t>Deterministic, local AI — nothing leaves the perimeter</a:t>
-            </a:r>
-            <a:endParaRPr lang="en-US" sz="1450" dirty="0"/>
+              <a:rPr lang="en-US" sz="1600" dirty="0">
+                <a:solidFill>
+                  <a:schemeClr val="bg1"/>
+                </a:solidFill>
+              </a:rPr>
+              <a:t>Includes a second enterprise solution: Freight Optimization for shipment consolidation and transportation savings </a:t>
+            </a:r>
           </a:p>
           <a:p>
             <a:pPr marL="203200" indent="-203200">
@@ -4693,17 +4794,18 @@
               <a:buChar char="•"/>
             </a:pPr>
             <a:r>
-              <a:rPr lang="en-US" sz="1450" dirty="0">
-                <a:solidFill>
-                  <a:srgbClr val="FFFFFF"/>
-                </a:solidFill>
-                <a:latin typeface="Calibri" pitchFamily="34" charset="0"/>
-                <a:ea typeface="Calibri" pitchFamily="34" charset="-122"/>
-                <a:cs typeface="Calibri" pitchFamily="34" charset="-120"/>
-              </a:rPr>
-              <a:t>Existing queues, SLAs, and approvals preserved</a:t>
-            </a:r>
-            <a:endParaRPr lang="en-US" sz="1450" dirty="0"/>
+              <a:rPr lang="en-US" sz="1600" dirty="0">
+                <a:solidFill>
+                  <a:schemeClr val="bg1"/>
+                </a:solidFill>
+              </a:rPr>
+              <a:t>Built as a scalable platform for future business workflows</a:t>
+            </a:r>
+            <a:endParaRPr lang="en-US" sz="1450" dirty="0">
+              <a:solidFill>
+                <a:schemeClr val="bg1"/>
+              </a:solidFill>
+            </a:endParaRPr>
           </a:p>
         </p:txBody>
       </p:sp>
@@ -4728,11 +4830,11 @@
           <a:bodyPr wrap="square" lIns="0" tIns="0" rIns="0" bIns="0" rtlCol="0" anchor="ctr"/>
           <a:lstStyle/>
           <a:p>
-            <a:pPr indent="0" marL="0">
-              <a:buNone/>
-            </a:pPr>
-            <a:r>
-              <a:rPr lang="en-US" sz="1300" b="1" spc="200" kern="0" dirty="0">
+            <a:pPr marL="0" indent="0">
+              <a:buNone/>
+            </a:pPr>
+            <a:r>
+              <a:rPr lang="en-US" sz="1300" b="1" kern="0" spc="200" dirty="0">
                 <a:solidFill>
                   <a:srgbClr val="CADCFC"/>
                 </a:solidFill>
@@ -4778,17 +4880,13 @@
               <a:buChar char="•"/>
             </a:pPr>
             <a:r>
-              <a:rPr lang="en-US" sz="1500" dirty="0">
-                <a:solidFill>
-                  <a:srgbClr val="FFFFFF"/>
-                </a:solidFill>
-                <a:latin typeface="Calibri" pitchFamily="34" charset="0"/>
-                <a:ea typeface="Calibri" pitchFamily="34" charset="-122"/>
-                <a:cs typeface="Calibri" pitchFamily="34" charset="-120"/>
-              </a:rPr>
-              <a:t>SSO-based roles replace the demo role selector</a:t>
-            </a:r>
-            <a:endParaRPr lang="en-US" sz="1500" dirty="0"/>
+              <a:rPr lang="en-US" sz="1600" dirty="0">
+                <a:solidFill>
+                  <a:schemeClr val="bg1"/>
+                </a:solidFill>
+              </a:rPr>
+              <a:t>SSO-based roles replace the demo role selector </a:t>
+            </a:r>
           </a:p>
           <a:p>
             <a:pPr marL="203200" indent="-203200">
@@ -4802,17 +4900,13 @@
               <a:buChar char="•"/>
             </a:pPr>
             <a:r>
-              <a:rPr lang="en-US" sz="1500" dirty="0">
-                <a:solidFill>
-                  <a:srgbClr val="FFFFFF"/>
-                </a:solidFill>
-                <a:latin typeface="Calibri" pitchFamily="34" charset="0"/>
-                <a:ea typeface="Calibri" pitchFamily="34" charset="-122"/>
-                <a:cs typeface="Calibri" pitchFamily="34" charset="-120"/>
-              </a:rPr>
-              <a:t>Live ServiceNow migration with validation counts</a:t>
-            </a:r>
-            <a:endParaRPr lang="en-US" sz="1500" dirty="0"/>
+              <a:rPr lang="en-US" sz="1600" dirty="0">
+                <a:solidFill>
+                  <a:schemeClr val="bg1"/>
+                </a:solidFill>
+              </a:rPr>
+              <a:t>Live ServiceNow migration with validation reporting </a:t>
+            </a:r>
           </a:p>
           <a:p>
             <a:pPr marL="203200" indent="-203200">
@@ -4826,17 +4920,13 @@
               <a:buChar char="•"/>
             </a:pPr>
             <a:r>
-              <a:rPr lang="en-US" sz="1500" dirty="0">
-                <a:solidFill>
-                  <a:srgbClr val="FFFFFF"/>
-                </a:solidFill>
-                <a:latin typeface="Calibri" pitchFamily="34" charset="0"/>
-                <a:ea typeface="Calibri" pitchFamily="34" charset="-122"/>
-                <a:cs typeface="Calibri" pitchFamily="34" charset="-120"/>
-              </a:rPr>
-              <a:t>Reconcile modeled savings vs. real ticket volume &amp; cost</a:t>
-            </a:r>
-            <a:endParaRPr lang="en-US" sz="1500" dirty="0"/>
+              <a:rPr lang="en-US" sz="1600" dirty="0">
+                <a:solidFill>
+                  <a:schemeClr val="bg1"/>
+                </a:solidFill>
+              </a:rPr>
+              <a:t>Category Owner workflow for governed template and request-category publishing </a:t>
+            </a:r>
           </a:p>
           <a:p>
             <a:pPr marL="203200" indent="-203200">
@@ -4850,17 +4940,13 @@
               <a:buChar char="•"/>
             </a:pPr>
             <a:r>
-              <a:rPr lang="en-US" sz="1500" dirty="0">
-                <a:solidFill>
-                  <a:srgbClr val="FFFFFF"/>
-                </a:solidFill>
-                <a:latin typeface="Calibri" pitchFamily="34" charset="0"/>
-                <a:ea typeface="Calibri" pitchFamily="34" charset="-122"/>
-                <a:cs typeface="Calibri" pitchFamily="34" charset="-120"/>
-              </a:rPr>
-              <a:t>Wire the classification regression harness into CI</a:t>
-            </a:r>
-            <a:endParaRPr lang="en-US" sz="1500" dirty="0"/>
+              <a:rPr lang="en-US" sz="1600" dirty="0">
+                <a:solidFill>
+                  <a:schemeClr val="bg1"/>
+                </a:solidFill>
+              </a:rPr>
+              <a:t>Expand Freight Optimization with live shipment and carrier integrations </a:t>
+            </a:r>
           </a:p>
           <a:p>
             <a:pPr marL="203200" indent="-203200">
@@ -4874,17 +4960,18 @@
               <a:buChar char="•"/>
             </a:pPr>
             <a:r>
-              <a:rPr lang="en-US" sz="1500" dirty="0">
-                <a:solidFill>
-                  <a:srgbClr val="FFFFFF"/>
-                </a:solidFill>
-                <a:latin typeface="Calibri" pitchFamily="34" charset="0"/>
-                <a:ea typeface="Calibri" pitchFamily="34" charset="-122"/>
-                <a:cs typeface="Calibri" pitchFamily="34" charset="-120"/>
-              </a:rPr>
-              <a:t>Real email intake and two-way notifications</a:t>
-            </a:r>
-            <a:endParaRPr lang="en-US" sz="1500" dirty="0"/>
+              <a:rPr lang="en-US" sz="1600" dirty="0">
+                <a:solidFill>
+                  <a:schemeClr val="bg1"/>
+                </a:solidFill>
+              </a:rPr>
+              <a:t>Real email intake with two-way requester notifications</a:t>
+            </a:r>
+            <a:endParaRPr lang="en-US" sz="1500" dirty="0">
+              <a:solidFill>
+                <a:schemeClr val="bg1"/>
+              </a:solidFill>
+            </a:endParaRPr>
           </a:p>
         </p:txBody>
       </p:sp>
@@ -4909,6 +4996,13 @@
           </a:solidFill>
           <a:ln/>
         </p:spPr>
+        <p:txBody>
+          <a:bodyPr/>
+          <a:lstStyle/>
+          <a:p>
+            <a:endParaRPr lang="en-US"/>
+          </a:p>
+        </p:txBody>
       </p:sp>
       <p:sp>
         <p:nvSpPr>
@@ -4931,7 +5025,7 @@
           <a:bodyPr wrap="square" lIns="0" tIns="0" rIns="0" bIns="0" rtlCol="0" anchor="ctr"/>
           <a:lstStyle/>
           <a:p>
-            <a:pPr indent="0" marL="0">
+            <a:pPr marL="0" indent="0">
               <a:buNone/>
             </a:pPr>
             <a:r>
@@ -5250,4 +5344,319 @@
     </a:ext>
   </a:extLst>
 </a:theme>
+</file>
+
+<file path=ppt/theme/theme2.xml><?xml version="1.0" encoding="utf-8"?>
+<a:theme xmlns:a="http://schemas.openxmlformats.org/drawingml/2006/main" name="Office Theme">
+  <a:themeElements>
+    <a:clrScheme name="Office">
+      <a:dk1>
+        <a:sysClr val="windowText" lastClr="000000"/>
+      </a:dk1>
+      <a:lt1>
+        <a:sysClr val="window" lastClr="FFFFFF"/>
+      </a:lt1>
+      <a:dk2>
+        <a:srgbClr val="0E2841"/>
+      </a:dk2>
+      <a:lt2>
+        <a:srgbClr val="E8E8E8"/>
+      </a:lt2>
+      <a:accent1>
+        <a:srgbClr val="156082"/>
+      </a:accent1>
+      <a:accent2>
+        <a:srgbClr val="E97132"/>
+      </a:accent2>
+      <a:accent3>
+        <a:srgbClr val="196B24"/>
+      </a:accent3>
+      <a:accent4>
+        <a:srgbClr val="0F9ED5"/>
+      </a:accent4>
+      <a:accent5>
+        <a:srgbClr val="A02B93"/>
+      </a:accent5>
+      <a:accent6>
+        <a:srgbClr val="4EA72E"/>
+      </a:accent6>
+      <a:hlink>
+        <a:srgbClr val="467886"/>
+      </a:hlink>
+      <a:folHlink>
+        <a:srgbClr val="96607D"/>
+      </a:folHlink>
+    </a:clrScheme>
+    <a:fontScheme name="Office">
+      <a:majorFont>
+        <a:latin typeface="Aptos Display" panose="02110004020202020204"/>
+        <a:ea typeface=""/>
+        <a:cs typeface=""/>
+        <a:font script="Jpan" typeface="游ゴシック Light"/>
+        <a:font script="Hang" typeface="맑은 고딕"/>
+        <a:font script="Hans" typeface="等线 Light"/>
+        <a:font script="Hant" typeface="新細明體"/>
+        <a:font script="Arab" typeface="Times New Roman"/>
+        <a:font script="Hebr" typeface="Times New Roman"/>
+        <a:font script="Thai" typeface="Angsana New"/>
+        <a:font script="Ethi" typeface="Nyala"/>
+        <a:font script="Beng" typeface="Vrinda"/>
+        <a:font script="Gujr" typeface="Shruti"/>
+        <a:font script="Khmr" typeface="MoolBoran"/>
+        <a:font script="Knda" typeface="Tunga"/>
+        <a:font script="Guru" typeface="Raavi"/>
+        <a:font script="Cans" typeface="Euphemia"/>
+        <a:font script="Cher" typeface="Plantagenet Cherokee"/>
+        <a:font script="Yiii" typeface="Microsoft Yi Baiti"/>
+        <a:font script="Tibt" typeface="Microsoft Himalaya"/>
+        <a:font script="Thaa" typeface="MV Boli"/>
+        <a:font script="Deva" typeface="Mangal"/>
+        <a:font script="Telu" typeface="Gautami"/>
+        <a:font script="Taml" typeface="Latha"/>
+        <a:font script="Syrc" typeface="Estrangelo Edessa"/>
+        <a:font script="Orya" typeface="Kalinga"/>
+        <a:font script="Mlym" typeface="Kartika"/>
+        <a:font script="Laoo" typeface="DokChampa"/>
+        <a:font script="Sinh" typeface="Iskoola Pota"/>
+        <a:font script="Mong" typeface="Mongolian Baiti"/>
+        <a:font script="Viet" typeface="Times New Roman"/>
+        <a:font script="Uigh" typeface="Microsoft Uighur"/>
+        <a:font script="Geor" typeface="Sylfaen"/>
+        <a:font script="Armn" typeface="Arial"/>
+        <a:font script="Bugi" typeface="Leelawadee UI"/>
+        <a:font script="Bopo" typeface="Microsoft JhengHei"/>
+        <a:font script="Java" typeface="Javanese Text"/>
+        <a:font script="Lisu" typeface="Segoe UI"/>
+        <a:font script="Mymr" typeface="Myanmar Text"/>
+        <a:font script="Nkoo" typeface="Ebrima"/>
+        <a:font script="Olck" typeface="Nirmala UI"/>
+        <a:font script="Osma" typeface="Ebrima"/>
+        <a:font script="Phag" typeface="Phagspa"/>
+        <a:font script="Syrn" typeface="Estrangelo Edessa"/>
+        <a:font script="Syrj" typeface="Estrangelo Edessa"/>
+        <a:font script="Syre" typeface="Estrangelo Edessa"/>
+        <a:font script="Sora" typeface="Nirmala UI"/>
+        <a:font script="Tale" typeface="Microsoft Tai Le"/>
+        <a:font script="Talu" typeface="Microsoft New Tai Lue"/>
+        <a:font script="Tfng" typeface="Ebrima"/>
+      </a:majorFont>
+      <a:minorFont>
+        <a:latin typeface="Aptos" panose="02110004020202020204"/>
+        <a:ea typeface=""/>
+        <a:cs typeface=""/>
+        <a:font script="Jpan" typeface="游ゴシック"/>
+        <a:font script="Hang" typeface="맑은 고딕"/>
+        <a:font script="Hans" typeface="等线"/>
+        <a:font script="Hant" typeface="新細明體"/>
+        <a:font script="Arab" typeface="Arial"/>
+        <a:font script="Hebr" typeface="Arial"/>
+        <a:font script="Thai" typeface="Cordia New"/>
+        <a:font script="Ethi" typeface="Nyala"/>
+        <a:font script="Beng" typeface="Vrinda"/>
+        <a:font script="Gujr" typeface="Shruti"/>
+        <a:font script="Khmr" typeface="DaunPenh"/>
+        <a:font script="Knda" typeface="Tunga"/>
+        <a:font script="Guru" typeface="Raavi"/>
+        <a:font script="Cans" typeface="Euphemia"/>
+        <a:font script="Cher" typeface="Plantagenet Cherokee"/>
+        <a:font script="Yiii" typeface="Microsoft Yi Baiti"/>
+        <a:font script="Tibt" typeface="Microsoft Himalaya"/>
+        <a:font script="Thaa" typeface="MV Boli"/>
+        <a:font script="Deva" typeface="Mangal"/>
+        <a:font script="Telu" typeface="Gautami"/>
+        <a:font script="Taml" typeface="Latha"/>
+        <a:font script="Syrc" typeface="Estrangelo Edessa"/>
+        <a:font script="Orya" typeface="Kalinga"/>
+        <a:font script="Mlym" typeface="Kartika"/>
+        <a:font script="Laoo" typeface="DokChampa"/>
+        <a:font script="Sinh" typeface="Iskoola Pota"/>
+        <a:font script="Mong" typeface="Mongolian Baiti"/>
+        <a:font script="Viet" typeface="Arial"/>
+        <a:font script="Uigh" typeface="Microsoft Uighur"/>
+        <a:font script="Geor" typeface="Sylfaen"/>
+        <a:font script="Armn" typeface="Arial"/>
+        <a:font script="Bugi" typeface="Leelawadee UI"/>
+        <a:font script="Bopo" typeface="Microsoft JhengHei"/>
+        <a:font script="Java" typeface="Javanese Text"/>
+        <a:font script="Lisu" typeface="Segoe UI"/>
+        <a:font script="Mymr" typeface="Myanmar Text"/>
+        <a:font script="Nkoo" typeface="Ebrima"/>
+        <a:font script="Olck" typeface="Nirmala UI"/>
+        <a:font script="Osma" typeface="Ebrima"/>
+        <a:font script="Phag" typeface="Phagspa"/>
+        <a:font script="Syrn" typeface="Estrangelo Edessa"/>
+        <a:font script="Syrj" typeface="Estrangelo Edessa"/>
+        <a:font script="Syre" typeface="Estrangelo Edessa"/>
+        <a:font script="Sora" typeface="Nirmala UI"/>
+        <a:font script="Tale" typeface="Microsoft Tai Le"/>
+        <a:font script="Talu" typeface="Microsoft New Tai Lue"/>
+        <a:font script="Tfng" typeface="Ebrima"/>
+      </a:minorFont>
+    </a:fontScheme>
+    <a:fmtScheme name="Office">
+      <a:fillStyleLst>
+        <a:solidFill>
+          <a:schemeClr val="phClr"/>
+        </a:solidFill>
+        <a:gradFill rotWithShape="1">
+          <a:gsLst>
+            <a:gs pos="0">
+              <a:schemeClr val="phClr">
+                <a:lumMod val="110000"/>
+                <a:satMod val="105000"/>
+                <a:tint val="67000"/>
+              </a:schemeClr>
+            </a:gs>
+            <a:gs pos="50000">
+              <a:schemeClr val="phClr">
+                <a:lumMod val="105000"/>
+                <a:satMod val="103000"/>
+                <a:tint val="73000"/>
+              </a:schemeClr>
+            </a:gs>
+            <a:gs pos="100000">
+              <a:schemeClr val="phClr">
+                <a:lumMod val="105000"/>
+                <a:satMod val="109000"/>
+                <a:tint val="81000"/>
+              </a:schemeClr>
+            </a:gs>
+          </a:gsLst>
+          <a:lin ang="5400000" scaled="0"/>
+        </a:gradFill>
+        <a:gradFill rotWithShape="1">
+          <a:gsLst>
+            <a:gs pos="0">
+              <a:schemeClr val="phClr">
+                <a:satMod val="103000"/>
+                <a:lumMod val="102000"/>
+                <a:tint val="94000"/>
+              </a:schemeClr>
+            </a:gs>
+            <a:gs pos="50000">
+              <a:schemeClr val="phClr">
+                <a:satMod val="110000"/>
+                <a:lumMod val="100000"/>
+                <a:shade val="100000"/>
+              </a:schemeClr>
+            </a:gs>
+            <a:gs pos="100000">
+              <a:schemeClr val="phClr">
+                <a:lumMod val="99000"/>
+                <a:satMod val="120000"/>
+                <a:shade val="78000"/>
+              </a:schemeClr>
+            </a:gs>
+          </a:gsLst>
+          <a:lin ang="5400000" scaled="0"/>
+        </a:gradFill>
+      </a:fillStyleLst>
+      <a:lnStyleLst>
+        <a:ln w="12700" cap="flat" cmpd="sng" algn="ctr">
+          <a:solidFill>
+            <a:schemeClr val="phClr"/>
+          </a:solidFill>
+          <a:prstDash val="solid"/>
+          <a:miter lim="800000"/>
+        </a:ln>
+        <a:ln w="19050" cap="flat" cmpd="sng" algn="ctr">
+          <a:solidFill>
+            <a:schemeClr val="phClr"/>
+          </a:solidFill>
+          <a:prstDash val="solid"/>
+          <a:miter lim="800000"/>
+        </a:ln>
+        <a:ln w="25400" cap="flat" cmpd="sng" algn="ctr">
+          <a:solidFill>
+            <a:schemeClr val="phClr"/>
+          </a:solidFill>
+          <a:prstDash val="solid"/>
+          <a:miter lim="800000"/>
+        </a:ln>
+      </a:lnStyleLst>
+      <a:effectStyleLst>
+        <a:effectStyle>
+          <a:effectLst/>
+        </a:effectStyle>
+        <a:effectStyle>
+          <a:effectLst/>
+        </a:effectStyle>
+        <a:effectStyle>
+          <a:effectLst>
+            <a:outerShdw blurRad="57150" dist="19050" dir="5400000" algn="ctr" rotWithShape="0">
+              <a:srgbClr val="000000">
+                <a:alpha val="63000"/>
+              </a:srgbClr>
+            </a:outerShdw>
+          </a:effectLst>
+        </a:effectStyle>
+      </a:effectStyleLst>
+      <a:bgFillStyleLst>
+        <a:solidFill>
+          <a:schemeClr val="phClr"/>
+        </a:solidFill>
+        <a:solidFill>
+          <a:schemeClr val="phClr">
+            <a:tint val="95000"/>
+            <a:satMod val="170000"/>
+          </a:schemeClr>
+        </a:solidFill>
+        <a:gradFill rotWithShape="1">
+          <a:gsLst>
+            <a:gs pos="0">
+              <a:schemeClr val="phClr">
+                <a:tint val="93000"/>
+                <a:satMod val="150000"/>
+                <a:shade val="98000"/>
+                <a:lumMod val="102000"/>
+              </a:schemeClr>
+            </a:gs>
+            <a:gs pos="50000">
+              <a:schemeClr val="phClr">
+                <a:tint val="98000"/>
+                <a:satMod val="130000"/>
+                <a:shade val="90000"/>
+                <a:lumMod val="103000"/>
+              </a:schemeClr>
+            </a:gs>
+            <a:gs pos="100000">
+              <a:schemeClr val="phClr">
+                <a:shade val="63000"/>
+                <a:satMod val="120000"/>
+              </a:schemeClr>
+            </a:gs>
+          </a:gsLst>
+          <a:lin ang="5400000" scaled="0"/>
+        </a:gradFill>
+      </a:bgFillStyleLst>
+    </a:fmtScheme>
+  </a:themeElements>
+  <a:objectDefaults>
+    <a:lnDef>
+      <a:spPr/>
+      <a:bodyPr/>
+      <a:lstStyle/>
+      <a:style>
+        <a:lnRef idx="2">
+          <a:schemeClr val="accent1"/>
+        </a:lnRef>
+        <a:fillRef idx="0">
+          <a:schemeClr val="accent1"/>
+        </a:fillRef>
+        <a:effectRef idx="1">
+          <a:schemeClr val="accent1"/>
+        </a:effectRef>
+        <a:fontRef idx="minor">
+          <a:schemeClr val="tx1"/>
+        </a:fontRef>
+      </a:style>
+    </a:lnDef>
+  </a:objectDefaults>
+  <a:extraClrSchemeLst/>
+  <a:extLst>
+    <a:ext uri="{05A4C25C-085E-4340-85A3-A5531E510DB2}">
+      <thm15:themeFamily xmlns:thm15="http://schemas.microsoft.com/office/thememl/2012/main" name="Office Theme" id="{2E142A2C-CD16-42D6-873A-C26D2A0506FA}" vid="{1BDDFF52-6CD6-40A5-AB3C-68EB2F1E4D0A}"/>
+    </a:ext>
+  </a:extLst>
+</a:theme>
 </file>
</xml_diff>